<commit_message>
feat: Programmatic template design for tech/casual/formal
- Create template_builder.py: zipfile + lxml based PPTX theme editor
- tech: dark bg (#1A1A2E), cyan accent, Consolas/Segoe UI fonts
- casual: warm white bg (#FFF8F0), orange accent, Fredoka/Nunito fonts
- formal: white bg (#FFFFFF), navy accent, Georgia/Calibri fonts
- Apply designs to all 3 template files in assets/
- 22 new tests (background, color scheme, fonts, differentiation)
- Total: 137 tests passed

🤖 Generated with Claude Code

Co-Authored-By: Claude <noreply@anthropic.com>
</commit_message>
<xml_diff>
--- a/skills/daida-ai/assets/templates/casual.pptx
+++ b/skills/daida-ai/assets/templates/casual.pptx
@@ -2570,9 +2570,12 @@
 <p:sldMaster xmlns:a="http://schemas.openxmlformats.org/drawingml/2006/main" xmlns:r="http://schemas.openxmlformats.org/officeDocument/2006/relationships" xmlns:p="http://schemas.openxmlformats.org/presentationml/2006/main">
   <p:cSld>
     <p:bg>
-      <p:bgRef idx="1001">
-        <a:schemeClr val="bg1"/>
-      </p:bgRef>
+      <p:bgPr>
+        <a:solidFill>
+          <a:srgbClr val="FFF8F0"/>
+        </a:solidFill>
+        <a:effectLst/>
+      </p:bgPr>
     </p:bg>
     <p:spTree>
       <p:nvGrpSpPr>
@@ -3077,52 +3080,52 @@
 </file>
 
 <file path=ppt/theme/theme1.xml><?xml version="1.0" encoding="utf-8"?>
-<a:theme xmlns:a="http://schemas.openxmlformats.org/drawingml/2006/main" name="Office Theme">
+<a:theme xmlns:a="http://schemas.openxmlformats.org/drawingml/2006/main" name="Casual Warm">
   <a:themeElements>
-    <a:clrScheme name="Office">
+    <a:clrScheme name="Casual">
       <a:dk1>
-        <a:sysClr val="windowText" lastClr="000000"/>
+        <a:srgbClr val="333333"/>
       </a:dk1>
       <a:lt1>
-        <a:sysClr val="window" lastClr="FFFFFF"/>
+        <a:srgbClr val="FFF8F0"/>
       </a:lt1>
       <a:dk2>
-        <a:srgbClr val="1F497D"/>
+        <a:srgbClr val="555555"/>
       </a:dk2>
       <a:lt2>
-        <a:srgbClr val="EEECE1"/>
+        <a:srgbClr val="FFF0E0"/>
       </a:lt2>
       <a:accent1>
-        <a:srgbClr val="4F81BD"/>
+        <a:srgbClr val="FF6B35"/>
       </a:accent1>
       <a:accent2>
-        <a:srgbClr val="C0504D"/>
+        <a:srgbClr val="F7C948"/>
       </a:accent2>
       <a:accent3>
-        <a:srgbClr val="9BBB59"/>
+        <a:srgbClr val="06D6A0"/>
       </a:accent3>
       <a:accent4>
-        <a:srgbClr val="8064A2"/>
+        <a:srgbClr val="118AB2"/>
       </a:accent4>
       <a:accent5>
-        <a:srgbClr val="4BACC6"/>
+        <a:srgbClr val="EF476F"/>
       </a:accent5>
       <a:accent6>
-        <a:srgbClr val="F79646"/>
+        <a:srgbClr val="8338EC"/>
       </a:accent6>
       <a:hlink>
-        <a:srgbClr val="0000FF"/>
+        <a:srgbClr val="118AB2"/>
       </a:hlink>
       <a:folHlink>
-        <a:srgbClr val="800080"/>
+        <a:srgbClr val="8338EC"/>
       </a:folHlink>
     </a:clrScheme>
     <a:fontScheme name="Office">
       <a:majorFont>
-        <a:latin typeface="Calibri"/>
+        <a:latin typeface="Fredoka"/>
         <a:ea typeface=""/>
         <a:cs typeface=""/>
-        <a:font script="Jpan" typeface="ＭＳ Ｐゴシック"/>
+        <a:font script="Jpan" typeface="M PLUS Rounded 1c"/>
         <a:font script="Hang" typeface="맑은 고딕"/>
         <a:font script="Hans" typeface="宋体"/>
         <a:font script="Hant" typeface="新細明體"/>
@@ -3154,10 +3157,10 @@
         <a:font script="Geor" typeface="Sylfaen"/>
       </a:majorFont>
       <a:minorFont>
-        <a:latin typeface="Calibri"/>
+        <a:latin typeface="Nunito"/>
         <a:ea typeface=""/>
         <a:cs typeface=""/>
-        <a:font script="Jpan" typeface="ＭＳ Ｐゴシック"/>
+        <a:font script="Jpan" typeface="M PLUS Rounded 1c"/>
         <a:font script="Hang" typeface="맑은 고딕"/>
         <a:font script="Hans" typeface="宋体"/>
         <a:font script="Hant" typeface="新細明體"/>

</xml_diff>